<commit_message>
fix: update Level 5 pitch deck (PPTX) titles and README links for Blue Belt submission
</commit_message>
<xml_diff>
--- a/docs/RoyaltyFlow_Level4_Pitch.pptx
+++ b/docs/RoyaltyFlow_Level4_Pitch.pptx
@@ -1766,7 +1766,7 @@
                 <a:ea typeface="Calibri" pitchFamily="34" charset="-122"/>
                 <a:cs typeface="Calibri" pitchFamily="34" charset="-120"/>
               </a:rPr>
-              <a:t>Level 4 Submission  —  User Onboarding, Feedback &amp; Growth</a:t>
+              <a:t>Level 5 Submission  —  User Onboarding, Feedback &amp; Growth</a:t>
             </a:r>
             <a:endParaRPr lang="en-US" sz="1400" dirty="0"/>
           </a:p>
@@ -2422,7 +2422,7 @@
                 <a:ea typeface="Calibri" pitchFamily="34" charset="-122"/>
                 <a:cs typeface="Calibri" pitchFamily="34" charset="-120"/>
               </a:rPr>
-              <a:t>RoyaltyFlow  •  Stellar Journey Level 4</a:t>
+              <a:t>RoyaltyFlow  •  Stellar Journey Level 5</a:t>
             </a:r>
             <a:endParaRPr lang="en-US" sz="1000" dirty="0"/>
           </a:p>
@@ -3206,7 +3206,7 @@
                 <a:ea typeface="Calibri" pitchFamily="34" charset="-122"/>
                 <a:cs typeface="Calibri" pitchFamily="34" charset="-120"/>
               </a:rPr>
-              <a:t>RoyaltyFlow  •  Stellar Journey Level 4</a:t>
+              <a:t>RoyaltyFlow  •  Stellar Journey Level 5</a:t>
             </a:r>
             <a:endParaRPr lang="en-US" sz="1000" dirty="0"/>
           </a:p>
@@ -4018,7 +4018,7 @@
                 <a:ea typeface="Calibri" pitchFamily="34" charset="-122"/>
                 <a:cs typeface="Calibri" pitchFamily="34" charset="-120"/>
               </a:rPr>
-              <a:t>RoyaltyFlow  •  Stellar Journey Level 4</a:t>
+              <a:t>RoyaltyFlow  •  Stellar Journey Level 5</a:t>
             </a:r>
             <a:endParaRPr lang="en-US" sz="1000" dirty="0"/>
           </a:p>
@@ -4890,7 +4890,7 @@
                 <a:ea typeface="Calibri" pitchFamily="34" charset="-122"/>
                 <a:cs typeface="Calibri" pitchFamily="34" charset="-120"/>
               </a:rPr>
-              <a:t>RoyaltyFlow  •  Stellar Journey Level 4</a:t>
+              <a:t>RoyaltyFlow  •  Stellar Journey Level 5</a:t>
             </a:r>
             <a:endParaRPr lang="en-US" sz="1000" dirty="0"/>
           </a:p>
@@ -6078,7 +6078,7 @@
                 <a:ea typeface="Calibri" pitchFamily="34" charset="-122"/>
                 <a:cs typeface="Calibri" pitchFamily="34" charset="-120"/>
               </a:rPr>
-              <a:t>RoyaltyFlow  •  Stellar Journey Level 4</a:t>
+              <a:t>RoyaltyFlow  •  Stellar Journey Level 5</a:t>
             </a:r>
             <a:endParaRPr lang="en-US" sz="1000" dirty="0"/>
           </a:p>
@@ -6695,7 +6695,7 @@
                 <a:ea typeface="Calibri" pitchFamily="34" charset="-122"/>
                 <a:cs typeface="Calibri" pitchFamily="34" charset="-120"/>
               </a:rPr>
-              <a:t>RoyaltyFlow  •  Stellar Journey Level 4</a:t>
+              <a:t>RoyaltyFlow  •  Stellar Journey Level 5</a:t>
             </a:r>
             <a:endParaRPr lang="en-US" sz="1000" dirty="0"/>
           </a:p>
@@ -7340,7 +7340,7 @@
                 <a:ea typeface="Calibri" pitchFamily="34" charset="-122"/>
                 <a:cs typeface="Calibri" pitchFamily="34" charset="-120"/>
               </a:rPr>
-              <a:t>RoyaltyFlow  •  Stellar Journey Level 4</a:t>
+              <a:t>RoyaltyFlow  •  Stellar Journey Level 5</a:t>
             </a:r>
             <a:endParaRPr lang="en-US" sz="1000" dirty="0"/>
           </a:p>

</xml_diff>